<commit_message>
Update loan diagram image and presentation
</commit_message>
<xml_diff>
--- a/Assignment3_Loan/Loan_Presentation.pptx
+++ b/Assignment3_Loan/Loan_Presentation.pptx
@@ -115,31 +115,31 @@
   <p:extLst>
     <p:ext uri="{521415D9-36F7-43E2-AB2F-B90AF26B5E84}">
       <p14:sectionLst xmlns:p14="http://schemas.microsoft.com/office/powerpoint/2010/main">
-        <p14:section name="Introduction" id="{bf31ef41-e566-4315-449b-782f73adae74}">
+        <p14:section name="Introduction" id="{23148770-bdeb-20e1-d3ac-6cf424bd6c12}">
           <p14:sldIdLst>
             <p14:sldId id="256"/>
             <p14:sldId id="257"/>
           </p14:sldIdLst>
         </p14:section>
-        <p14:section name="Process" id="{4e4d1b71-0ace-c4fb-0a1f-d1b97fe02f1d}">
+        <p14:section name="Process" id="{93c135b5-e81d-631a-d7f5-24c1e8c1b7b9}">
           <p14:sldIdLst>
             <p14:sldId id="258"/>
           </p14:sldIdLst>
         </p14:section>
-        <p14:section name="Task types, gateways and events" id="{94626242-844e-d9e7-068c-1625ee4d56b7}">
+        <p14:section name="Task types, gateways and events" id="{6d6b8c52-4124-5b19-c3a9-ebd53721be6a}">
           <p14:sldIdLst>
             <p14:sldId id="259"/>
             <p14:sldId id="260"/>
             <p14:sldId id="261"/>
           </p14:sldIdLst>
         </p14:section>
-        <p14:section name="Critical and alternate paths" id="{5711a2b0-82e2-8a56-c369-1ac57b7839ab}">
+        <p14:section name="Critical and alternate paths" id="{588c0ebb-cc8a-ae44-8b60-f21f407677a4}">
           <p14:sldIdLst>
             <p14:sldId id="262"/>
             <p14:sldId id="263"/>
           </p14:sldIdLst>
         </p14:section>
-        <p14:section name="Summary" id="{fe2c2434-2284-1442-2b3f-2107451b29dd}">
+        <p14:section name="Summary" id="{8bf7da35-fcc5-3555-91d9-80d0eb8f5fdb}">
           <p14:sldIdLst>
             <p14:sldId id="264"/>
           </p14:sldIdLst>
@@ -2200,42 +2200,6 @@
             <a:prstDash val="solid"/>
           </a:ln>
         </p:spPr>
-      </p:sp>
-      <p:sp>
-        <p:nvSpPr>
-          <p:cNvPr id="11" name="Text 9"/>
-          <p:cNvSpPr txBox="1"/>
-          <p:nvPr/>
-        </p:nvSpPr>
-        <p:spPr>
-          <a:xfrm>
-            <a:off x="731520" y="5669280"/>
-            <a:ext cx="10698480" cy="365760"/>
-          </a:xfrm>
-          <a:prstGeom prst="rect">
-            <a:avLst/>
-          </a:prstGeom>
-          <a:noFill/>
-          <a:ln/>
-        </p:spPr>
-        <p:txBody>
-          <a:bodyPr wrap="square" lIns="0" tIns="0" rIns="0" bIns="0" rtlCol="0" anchor="ctr"/>
-          <a:lstStyle/>
-          <a:p>
-            <a:pPr indent="0" marL="0">
-              <a:buNone/>
-            </a:pPr>
-            <a:r>
-              <a:rPr lang="en-US" sz="1600" dirty="0">
-                <a:solidFill>
-                  <a:srgbClr val="C9D2E0"/>
-                </a:solidFill>
-              </a:rPr>
-              <a:t>[Your name]  ·  [Roll number]  ·  [Course]</a:t>
-            </a:r>
-            <a:endParaRPr lang="en-US" sz="1600" dirty="0"/>
-          </a:p>
-        </p:txBody>
       </p:sp>
     </p:spTree>
   </p:cSld>

</xml_diff>